<commit_message>
Align the V6 deck with the implemented Go tier and link the Python implementation
The temporal-properties slide presents user-supplied stored attributes, the
temporal-geometry slide shows the TemporalGeometrySequence envelope with member
ids, the derived-measure paths address a 1-based member index, and the references
slide links the Python implementation at github.com/MobilityDB/MobilityAPI-Python.
</commit_message>
<xml_diff>
--- a/MobilityAPIV6.pptx
+++ b/MobilityAPIV6.pptx
@@ -17391,7 +17391,7 @@
                 </a:solidFill>
                 <a:latin typeface="Consolas"/>
               </a:rPr>
-              <a:t>"MovingPoint"</a:t>
+              <a:t>"TemporalGeometrySequence"</a:t>
             </a:r>
             <a:r>
               <a:rPr sz="1200">
@@ -17583,7 +17583,7 @@
                 </a:solidFill>
                 <a:latin typeface="Consolas"/>
               </a:rPr>
-              <a:t>"sequences"</a:t>
+              <a:t>"geometrySequence"</a:t>
             </a:r>
             <a:r>
               <a:rPr sz="1200">
@@ -17614,7 +17614,7 @@
                 </a:solidFill>
                 <a:latin typeface="Consolas"/>
               </a:rPr>
-              <a:t>    { </a:t>
+              <a:t>    { "id": 1, "type": "MovingPoint", </a:t>
             </a:r>
             <a:r>
               <a:rPr sz="1200">
@@ -18646,7 +18646,7 @@
                 </a:solidFill>
                 <a:latin typeface="Consolas"/>
               </a:rPr>
-              <a:t>/collections/ships/items/1/tgsequence/0/velocity</a:t>
+              <a:t>/collections/ships/items/1/tgsequence/1/velocity</a:t>
             </a:r>
           </a:p>
         </p:txBody>
@@ -19340,7 +19340,7 @@
                 </a:solidFill>
                 <a:latin typeface="Consolas"/>
               </a:rPr>
-              <a:t>/collections/ships/items/1/tgsequence/0/acceleration</a:t>
+              <a:t>/collections/ships/items/1/tgsequence/1/acceleration</a:t>
             </a:r>
           </a:p>
         </p:txBody>
@@ -21623,7 +21623,7 @@
                 </a:solidFill>
                 <a:latin typeface="Consolas"/>
               </a:rPr>
-              <a:t>"velocity"</a:t>
+              <a:t>"fuel"</a:t>
             </a:r>
             <a:r>
               <a:rPr sz="1200" dirty="0">
@@ -21713,7 +21713,7 @@
                 </a:solidFill>
                 <a:latin typeface="Consolas"/>
               </a:rPr>
-              <a:t>"m/s"</a:t>
+              <a:t>"L"</a:t>
             </a:r>
             <a:r>
               <a:rPr sz="1200" dirty="0">
@@ -21771,7 +21771,7 @@
                 </a:solidFill>
                 <a:latin typeface="Consolas"/>
               </a:rPr>
-              <a:t>"distance"</a:t>
+              <a:t>"cargo_temp"</a:t>
             </a:r>
             <a:r>
               <a:rPr sz="1200" dirty="0">
@@ -21861,7 +21861,7 @@
                 </a:solidFill>
                 <a:latin typeface="Consolas"/>
               </a:rPr>
-              <a:t>"m"</a:t>
+              <a:t>"Cel"</a:t>
             </a:r>
             <a:r>
               <a:rPr sz="1200" dirty="0">
@@ -21919,7 +21919,7 @@
                 </a:solidFill>
                 <a:latin typeface="Consolas"/>
               </a:rPr>
-              <a:t>"heading"</a:t>
+              <a:t>"load"</a:t>
             </a:r>
             <a:r>
               <a:rPr sz="1200" dirty="0">
@@ -22009,7 +22009,7 @@
                 </a:solidFill>
                 <a:latin typeface="Consolas"/>
               </a:rPr>
-              <a:t>"rad"</a:t>
+              <a:t>"t"</a:t>
             </a:r>
             <a:r>
               <a:rPr sz="1200" dirty="0">
@@ -22329,7 +22329,7 @@
                 </a:solidFill>
                 <a:latin typeface="Consolas"/>
               </a:rPr>
-              <a:t>/collections/ships/items/1/tproperties/velocity?leaf=...</a:t>
+              <a:t>/collections/ships/items/1/tproperties/fuel?leaf=...</a:t>
             </a:r>
           </a:p>
         </p:txBody>
@@ -22448,7 +22448,7 @@
                 </a:solidFill>
                 <a:latin typeface="Consolas"/>
               </a:rPr>
-              <a:t>"velocity"</a:t>
+              <a:t>"fuel"</a:t>
             </a:r>
             <a:r>
               <a:rPr sz="1200">
@@ -22520,7 +22520,7 @@
                 </a:solidFill>
                 <a:latin typeface="Consolas"/>
               </a:rPr>
-              <a:t>"m/s"</a:t>
+              <a:t>"L"</a:t>
             </a:r>
             <a:r>
               <a:rPr sz="1200">
@@ -31027,7 +31027,7 @@
         </p:nvSpPr>
         <p:spPr>
           <a:xfrm>
-            <a:off x="566928" y="1389888"/>
+            <a:off x="566928" y="1159888"/>
             <a:ext cx="1554480" cy="45720"/>
           </a:xfrm>
           <a:prstGeom prst="rect">
@@ -31072,7 +31072,7 @@
         </p:nvSpPr>
         <p:spPr>
           <a:xfrm>
-            <a:off x="566928" y="1993392"/>
+            <a:off x="566928" y="1763392"/>
             <a:ext cx="164592" cy="164592"/>
           </a:xfrm>
           <a:prstGeom prst="rect">
@@ -31117,7 +31117,7 @@
         </p:nvSpPr>
         <p:spPr>
           <a:xfrm>
-            <a:off x="932688" y="1920240"/>
+            <a:off x="932688" y="1690240"/>
             <a:ext cx="8686800" cy="320040"/>
           </a:xfrm>
           <a:prstGeom prst="rect">
@@ -31159,7 +31159,7 @@
         </p:nvSpPr>
         <p:spPr>
           <a:xfrm>
-            <a:off x="932688" y="2231136"/>
+            <a:off x="932688" y="2001136"/>
             <a:ext cx="10515600" cy="292608"/>
           </a:xfrm>
           <a:prstGeom prst="rect">
@@ -31195,7 +31195,7 @@
         </p:nvSpPr>
         <p:spPr>
           <a:xfrm>
-            <a:off x="566928" y="2834640"/>
+            <a:off x="566928" y="2604640"/>
             <a:ext cx="164592" cy="164592"/>
           </a:xfrm>
           <a:prstGeom prst="rect">
@@ -31240,7 +31240,7 @@
         </p:nvSpPr>
         <p:spPr>
           <a:xfrm>
-            <a:off x="932688" y="2761488"/>
+            <a:off x="932688" y="2531488"/>
             <a:ext cx="8686800" cy="320040"/>
           </a:xfrm>
           <a:prstGeom prst="rect">
@@ -31282,7 +31282,7 @@
         </p:nvSpPr>
         <p:spPr>
           <a:xfrm>
-            <a:off x="932688" y="3072384"/>
+            <a:off x="932688" y="2842384"/>
             <a:ext cx="10515600" cy="292608"/>
           </a:xfrm>
           <a:prstGeom prst="rect">
@@ -31337,7 +31337,7 @@
         </p:nvSpPr>
         <p:spPr>
           <a:xfrm>
-            <a:off x="566928" y="3675887"/>
+            <a:off x="566928" y="3445887"/>
             <a:ext cx="164592" cy="164592"/>
           </a:xfrm>
           <a:prstGeom prst="rect">
@@ -31382,7 +31382,7 @@
         </p:nvSpPr>
         <p:spPr>
           <a:xfrm>
-            <a:off x="932688" y="3602736"/>
+            <a:off x="932688" y="3372736"/>
             <a:ext cx="8686800" cy="320040"/>
           </a:xfrm>
           <a:prstGeom prst="rect">
@@ -31424,7 +31424,7 @@
         </p:nvSpPr>
         <p:spPr>
           <a:xfrm>
-            <a:off x="932688" y="3913632"/>
+            <a:off x="932688" y="3683632"/>
             <a:ext cx="10515600" cy="292608"/>
           </a:xfrm>
           <a:prstGeom prst="rect">
@@ -31460,7 +31460,7 @@
         </p:nvSpPr>
         <p:spPr>
           <a:xfrm>
-            <a:off x="566928" y="4517136"/>
+            <a:off x="566928" y="4287136"/>
             <a:ext cx="164592" cy="164592"/>
           </a:xfrm>
           <a:prstGeom prst="rect">
@@ -31505,7 +31505,7 @@
         </p:nvSpPr>
         <p:spPr>
           <a:xfrm>
-            <a:off x="932688" y="4443984"/>
+            <a:off x="932688" y="4213984"/>
             <a:ext cx="8686800" cy="320040"/>
           </a:xfrm>
           <a:prstGeom prst="rect">
@@ -31547,7 +31547,7 @@
         </p:nvSpPr>
         <p:spPr>
           <a:xfrm>
-            <a:off x="932688" y="4754880"/>
+            <a:off x="932688" y="4524880"/>
             <a:ext cx="10515600" cy="292608"/>
           </a:xfrm>
           <a:prstGeom prst="rect">
@@ -31712,7 +31712,7 @@
         </p:nvSpPr>
         <p:spPr>
           <a:xfrm>
-            <a:off x="566928" y="5358384"/>
+            <a:off x="566928" y="5128384"/>
             <a:ext cx="164592" cy="164592"/>
           </a:xfrm>
           <a:prstGeom prst="rect">
@@ -31757,7 +31757,7 @@
         </p:nvSpPr>
         <p:spPr>
           <a:xfrm>
-            <a:off x="932688" y="5285232"/>
+            <a:off x="932688" y="5055232"/>
             <a:ext cx="8686800" cy="320040"/>
           </a:xfrm>
           <a:prstGeom prst="rect">
@@ -31799,7 +31799,7 @@
         </p:nvSpPr>
         <p:spPr>
           <a:xfrm>
-            <a:off x="932688" y="5596128"/>
+            <a:off x="932688" y="5366128"/>
             <a:ext cx="10515600" cy="292608"/>
           </a:xfrm>
           <a:prstGeom prst="rect">
@@ -31823,6 +31823,129 @@
                 <a:hlinkClick r:id="rId7"/>
               </a:rPr>
               <a:t>https://github.com/MobilityDB/MobilityAPI/blob/master/tutorial/tutorial.ipynb</a:t>
+            </a:r>
+          </a:p>
+        </p:txBody>
+      </p:sp>
+      <p:sp>
+        <p:nvSpPr>
+          <p:cNvPr id="20" name="Rectangle 19"/>
+          <p:cNvSpPr/>
+          <p:nvPr/>
+        </p:nvSpPr>
+        <p:spPr>
+          <a:xfrm>
+            <a:off x="566928" y="5969632"/>
+            <a:ext cx="164592" cy="164592"/>
+          </a:xfrm>
+          <a:prstGeom prst="rect">
+            <a:avLst/>
+          </a:prstGeom>
+          <a:solidFill>
+            <a:srgbClr val="156082"/>
+          </a:solidFill>
+          <a:ln>
+            <a:noFill/>
+          </a:ln>
+          <a:effectLst/>
+        </p:spPr>
+        <p:style>
+          <a:lnRef idx="1">
+            <a:schemeClr val="accent1"/>
+          </a:lnRef>
+          <a:fillRef idx="3">
+            <a:schemeClr val="accent1"/>
+          </a:fillRef>
+          <a:effectRef idx="2">
+            <a:schemeClr val="accent1"/>
+          </a:effectRef>
+          <a:fontRef idx="minor">
+            <a:schemeClr val="lt1"/>
+          </a:fontRef>
+        </p:style>
+        <p:txBody>
+          <a:bodyPr rtlCol="0" anchor="ctr"/>
+          <a:lstStyle/>
+          <a:p>
+            <a:pPr algn="ctr"/>
+            <a:endParaRPr/>
+          </a:p>
+        </p:txBody>
+      </p:sp>
+      <p:sp>
+        <p:nvSpPr>
+          <p:cNvPr id="21" name="TextBox 20"/>
+          <p:cNvSpPr txBox="1"/>
+          <p:nvPr/>
+        </p:nvSpPr>
+        <p:spPr>
+          <a:xfrm>
+            <a:off x="932688" y="5896480"/>
+            <a:ext cx="8686800" cy="320040"/>
+          </a:xfrm>
+          <a:prstGeom prst="rect">
+            <a:avLst/>
+          </a:prstGeom>
+          <a:noFill/>
+        </p:spPr>
+        <p:txBody>
+          <a:bodyPr wrap="square" lIns="0" tIns="0" rIns="0" bIns="0" anchor="t">
+            <a:noAutofit/>
+          </a:bodyPr>
+          <a:lstStyle/>
+          <a:p>
+            <a:pPr algn="l">
+              <a:spcBef>
+                <a:spcPts val="0"/>
+              </a:spcBef>
+              <a:spcAft>
+                <a:spcPts val="200"/>
+              </a:spcAft>
+            </a:pPr>
+            <a:r>
+              <a:rPr sz="1400" b="1" i="0">
+                <a:solidFill>
+                  <a:srgbClr val="0E2841"/>
+                </a:solidFill>
+                <a:latin typeface="Calibri"/>
+              </a:rPr>
+              <a:t>MobilityAPI — Python implementation (PyMEOS)</a:t>
+            </a:r>
+          </a:p>
+        </p:txBody>
+      </p:sp>
+      <p:sp>
+        <p:nvSpPr>
+          <p:cNvPr id="22" name="TextBox 21"/>
+          <p:cNvSpPr txBox="1"/>
+          <p:nvPr/>
+        </p:nvSpPr>
+        <p:spPr>
+          <a:xfrm>
+            <a:off x="932688" y="6207376"/>
+            <a:ext cx="10515600" cy="292608"/>
+          </a:xfrm>
+          <a:prstGeom prst="rect">
+            <a:avLst/>
+          </a:prstGeom>
+          <a:noFill/>
+        </p:spPr>
+        <p:txBody>
+          <a:bodyPr wrap="none" lIns="0" tIns="0" rIns="0" bIns="0">
+            <a:noAutofit/>
+          </a:bodyPr>
+          <a:lstStyle/>
+          <a:p>
+            <a:pPr algn="l"/>
+            <a:r>
+              <a:rPr sz="1200" u="none">
+                <a:solidFill>
+                  <a:srgbClr val="156082"/>
+                </a:solidFill>
+                <a:latin typeface="Consolas"/>
+                <a:hlinkClick r:id="rId7"/>
+              </a:rPr>
+              <a:t>https://github.com/MobilityDB/MobilityAPI-Python</a:t>
             </a:r>
           </a:p>
         </p:txBody>

</xml_diff>

<commit_message>
Align the V6 deck with the implemented surface
The deck presents temporal properties as user-supplied values stored as native MobilityDB temporal values and written and removed over HTTP, member-geometry deletion and collection CRUD alongside the other extensions, the implemented temporal-property types, and the aistairc/mf-api reference implementation in the references.
</commit_message>
<xml_diff>
--- a/MobilityAPIV6.pptx
+++ b/MobilityAPIV6.pptx
@@ -16782,7 +16782,7 @@
                 </a:solidFill>
                 <a:latin typeface="Calibri"/>
               </a:rPr>
-              <a:t>Derived properties:  </a:t>
+              <a:t>Derived measures:  </a:t>
             </a:r>
             <a:r>
               <a:rPr sz="1200">
@@ -16791,7 +16791,7 @@
                 </a:solidFill>
                 <a:latin typeface="Calibri"/>
               </a:rPr>
-              <a:t>computed from the geometry, so writes to them return 501; modify the geometry instead</a:t>
+              <a:t>velocity and distance are computed from the geometry and are read-only; change the geometry to change them</a:t>
             </a:r>
           </a:p>
           <a:p>
@@ -16822,7 +16822,7 @@
                 </a:solidFill>
                 <a:latin typeface="Calibri"/>
               </a:rPr>
-              <a:t>Single geometry:  </a:t>
+              <a:t>Member delete:  </a:t>
             </a:r>
             <a:r>
               <a:rPr sz="1200">
@@ -16831,7 +16831,7 @@
                 </a:solidFill>
                 <a:latin typeface="Calibri"/>
               </a:rPr>
-              <a:t>a feature carries one temporal geometry; delete the feature rather than a primitive</a:t>
+              <a:t>DELETE /…/tgsequence/{id} drops one geometry member by index via deleteTime; DELETE on the item removes the whole feature</a:t>
             </a:r>
           </a:p>
         </p:txBody>
@@ -22827,7 +22827,7 @@
                 </a:solidFill>
                 <a:latin typeface="Calibri"/>
               </a:rPr>
-              <a:t>TBoolean · TText · TInteger · TReal · TImage</a:t>
+              <a:t>TBoolean · TText · TInteger · TReal</a:t>
             </a:r>
           </a:p>
         </p:txBody>
@@ -22881,7 +22881,7 @@
                 </a:solidFill>
                 <a:latin typeface="Calibri"/>
               </a:rPr>
-              <a:t>Derived:  </a:t>
+              <a:t>Stored:  </a:t>
             </a:r>
             <a:r>
               <a:rPr sz="1200">
@@ -22890,7 +22890,7 @@
                 </a:solidFill>
                 <a:latin typeface="Calibri"/>
               </a:rPr>
-              <a:t>velocity, distance and heading are computed from the trajectory, read-only</a:t>
+              <a:t>user-supplied attributes — fuel, cargo temperature, load — held as native MobilityDB temporal values</a:t>
             </a:r>
           </a:p>
           <a:p>
@@ -22921,7 +22921,7 @@
                 </a:solidFill>
                 <a:latin typeface="Calibri"/>
               </a:rPr>
-              <a:t>valueSequence:  </a:t>
+              <a:t>Writable:  </a:t>
             </a:r>
             <a:r>
               <a:rPr sz="1200">
@@ -22930,7 +22930,7 @@
                 </a:solidFill>
                 <a:latin typeface="Calibri"/>
               </a:rPr>
-              <a:t>datetimes and values with each segment's true interpolation</a:t>
+              <a:t>POST creates a property, POST appends values via merge, DELETE removes it</a:t>
             </a:r>
           </a:p>
           <a:p>
@@ -22961,7 +22961,7 @@
                 </a:solidFill>
                 <a:latin typeface="Calibri"/>
               </a:rPr>
-              <a:t>leaf:  </a:t>
+              <a:t>valueSequence:  </a:t>
             </a:r>
             <a:r>
               <a:rPr sz="1200">
@@ -22970,7 +22970,7 @@
                 </a:solidFill>
                 <a:latin typeface="Calibri"/>
               </a:rPr>
-              <a:t>selects values at given instants; the result is Discrete</a:t>
+              <a:t>datetimes and values with each segment's true interpolation</a:t>
             </a:r>
           </a:p>
           <a:p>
@@ -23001,7 +23001,7 @@
                 </a:solidFill>
                 <a:latin typeface="Calibri"/>
               </a:rPr>
-              <a:t>datetime:  </a:t>
+              <a:t>leaf / datetime:  </a:t>
             </a:r>
             <a:r>
               <a:rPr sz="1200">
@@ -23010,7 +23010,7 @@
                 </a:solidFill>
                 <a:latin typeface="Calibri"/>
               </a:rPr>
-              <a:t>clips the property to an interval</a:t>
+              <a:t>leaf selects values at given instants (Discrete); datetime clips to an interval</a:t>
             </a:r>
           </a:p>
         </p:txBody>
@@ -25767,6 +25767,86 @@
               <a:t>compressed request and response bodies</a:t>
             </a:r>
           </a:p>
+          <a:p>
+            <a:pPr>
+              <a:lnSpc>
+                <a:spcPct val="106000"/>
+              </a:lnSpc>
+              <a:spcBef>
+                <a:spcPts val="0"/>
+              </a:spcBef>
+              <a:spcAft>
+                <a:spcPts val="1600"/>
+              </a:spcAft>
+            </a:pPr>
+            <a:r>
+              <a:rPr sz="1600" b="1" dirty="0">
+                <a:solidFill>
+                  <a:srgbClr val="156082"/>
+                </a:solidFill>
+                <a:latin typeface="Calibri"/>
+              </a:rPr>
+              <a:t>▸  </a:t>
+            </a:r>
+            <a:r>
+              <a:rPr sz="1600" b="1" dirty="0" err="1">
+                <a:solidFill>
+                  <a:srgbClr val="0E2841"/>
+                </a:solidFill>
+                <a:latin typeface="Calibri"/>
+              </a:rPr>
+              <a:t>POST / PUT / DELETE  /collections  </a:t>
+            </a:r>
+            <a:r>
+              <a:rPr sz="1600" b="0" dirty="0">
+                <a:solidFill>
+                  <a:srgbClr val="1E2B36"/>
+                </a:solidFill>
+                <a:latin typeface="Calibri"/>
+              </a:rPr>
+              <a:t>create, update and drop a collection and its feature table</a:t>
+            </a:r>
+          </a:p>
+          <a:p>
+            <a:pPr>
+              <a:lnSpc>
+                <a:spcPct val="106000"/>
+              </a:lnSpc>
+              <a:spcBef>
+                <a:spcPts val="0"/>
+              </a:spcBef>
+              <a:spcAft>
+                <a:spcPts val="1600"/>
+              </a:spcAft>
+            </a:pPr>
+            <a:r>
+              <a:rPr sz="1600" b="1" dirty="0">
+                <a:solidFill>
+                  <a:srgbClr val="156082"/>
+                </a:solidFill>
+                <a:latin typeface="Calibri"/>
+              </a:rPr>
+              <a:t>▸  </a:t>
+            </a:r>
+            <a:r>
+              <a:rPr sz="1600" b="1" dirty="0" err="1">
+                <a:solidFill>
+                  <a:srgbClr val="0E2841"/>
+                </a:solidFill>
+                <a:latin typeface="Calibri"/>
+              </a:rPr>
+              <a:t>POST / DELETE  /…/tproperties  </a:t>
+            </a:r>
+            <a:r>
+              <a:rPr sz="1600" b="0" dirty="0">
+                <a:solidFill>
+                  <a:srgbClr val="1E2B36"/>
+                </a:solidFill>
+                <a:latin typeface="Calibri"/>
+              </a:rPr>
+              <a:t>store and remove user-supplied TReal / TInt / TText / TBool attributes</a:t>
+            </a:r>
+          </a:p>
         </p:txBody>
       </p:sp>
       <p:sp>
@@ -29968,6 +30048,34 @@
               <a:t>datetime / leaf clip</a:t>
             </a:r>
           </a:p>
+          <a:p>
+            <a:pPr>
+              <a:lnSpc>
+                <a:spcPct val="100000"/>
+              </a:lnSpc>
+              <a:spcAft>
+                <a:spcPts val="300"/>
+              </a:spcAft>
+            </a:pPr>
+            <a:r>
+              <a:rPr sz="1200" b="1">
+                <a:solidFill>
+                  <a:srgbClr val="A02B93"/>
+                </a:solidFill>
+                <a:latin typeface="Calibri"/>
+              </a:rPr>
+              <a:t>✓ </a:t>
+            </a:r>
+            <a:r>
+              <a:rPr sz="1200">
+                <a:solidFill>
+                  <a:srgbClr val="1E2B36"/>
+                </a:solidFill>
+                <a:latin typeface="Calibri"/>
+              </a:rPr>
+              <a:t>member delete (DELETE)</a:t>
+            </a:r>
+          </a:p>
         </p:txBody>
       </p:sp>
       <p:sp>
@@ -31072,7 +31180,7 @@
         </p:nvSpPr>
         <p:spPr>
           <a:xfrm>
-            <a:off x="566928" y="1763392"/>
+            <a:off x="566928" y="1554480"/>
             <a:ext cx="164592" cy="164592"/>
           </a:xfrm>
           <a:prstGeom prst="rect">
@@ -31111,91 +31219,13 @@
       </p:sp>
       <p:sp>
         <p:nvSpPr>
-          <p:cNvPr id="6" name="TextBox 5"/>
-          <p:cNvSpPr txBox="1"/>
-          <p:nvPr/>
-        </p:nvSpPr>
-        <p:spPr>
-          <a:xfrm>
-            <a:off x="932688" y="1690240"/>
-            <a:ext cx="8686800" cy="320040"/>
-          </a:xfrm>
-          <a:prstGeom prst="rect">
-            <a:avLst/>
-          </a:prstGeom>
-          <a:noFill/>
-        </p:spPr>
-        <p:txBody>
-          <a:bodyPr wrap="square" lIns="0" tIns="0" rIns="0" bIns="0" anchor="t">
-            <a:noAutofit/>
-          </a:bodyPr>
-          <a:lstStyle/>
-          <a:p>
-            <a:pPr algn="l">
-              <a:spcBef>
-                <a:spcPts val="0"/>
-              </a:spcBef>
-              <a:spcAft>
-                <a:spcPts val="200"/>
-              </a:spcAft>
-            </a:pPr>
-            <a:r>
-              <a:rPr sz="1400" b="1" i="0">
-                <a:solidFill>
-                  <a:srgbClr val="0E2841"/>
-                </a:solidFill>
-                <a:latin typeface="Calibri"/>
-              </a:rPr>
-              <a:t>OGC API – Moving Features – Part 1: Core</a:t>
-            </a:r>
-          </a:p>
-        </p:txBody>
-      </p:sp>
-      <p:sp>
-        <p:nvSpPr>
-          <p:cNvPr id="7" name="TextBox 6"/>
-          <p:cNvSpPr txBox="1"/>
-          <p:nvPr/>
-        </p:nvSpPr>
-        <p:spPr>
-          <a:xfrm>
-            <a:off x="932688" y="2001136"/>
-            <a:ext cx="10515600" cy="292608"/>
-          </a:xfrm>
-          <a:prstGeom prst="rect">
-            <a:avLst/>
-          </a:prstGeom>
-          <a:noFill/>
-        </p:spPr>
-        <p:txBody>
-          <a:bodyPr wrap="none" lIns="0" tIns="0" rIns="0" bIns="0">
-            <a:noAutofit/>
-          </a:bodyPr>
-          <a:lstStyle/>
-          <a:p>
-            <a:pPr algn="l"/>
-            <a:r>
-              <a:rPr sz="1200" u="none">
-                <a:solidFill>
-                  <a:srgbClr val="156082"/>
-                </a:solidFill>
-                <a:latin typeface="Consolas"/>
-                <a:hlinkClick r:id="rId2"/>
-              </a:rPr>
-              <a:t>https://docs.ogc.org/is/22-003r3/22-003r3.html</a:t>
-            </a:r>
-          </a:p>
-        </p:txBody>
-      </p:sp>
-      <p:sp>
-        <p:nvSpPr>
-          <p:cNvPr id="8" name="Rectangle 7"/>
+          <p:cNvPr id="5" name="Rectangle 4"/>
           <p:cNvSpPr/>
           <p:nvPr/>
         </p:nvSpPr>
         <p:spPr>
           <a:xfrm>
-            <a:off x="566928" y="2604640"/>
+            <a:off x="566928" y="5833872"/>
             <a:ext cx="164592" cy="164592"/>
           </a:xfrm>
           <a:prstGeom prst="rect">
@@ -31234,13 +31264,13 @@
       </p:sp>
       <p:sp>
         <p:nvSpPr>
-          <p:cNvPr id="9" name="TextBox 8"/>
+          <p:cNvPr id="6" name="TextBox 5"/>
           <p:cNvSpPr txBox="1"/>
           <p:nvPr/>
         </p:nvSpPr>
         <p:spPr>
           <a:xfrm>
-            <a:off x="932688" y="2531488"/>
+            <a:off x="932688" y="1481328"/>
             <a:ext cx="8686800" cy="320040"/>
           </a:xfrm>
           <a:prstGeom prst="rect">
@@ -31269,20 +31299,20 @@
                 </a:solidFill>
                 <a:latin typeface="Calibri"/>
               </a:rPr>
-              <a:t>MobilityDB</a:t>
-            </a:r>
-          </a:p>
-        </p:txBody>
-      </p:sp>
-      <p:sp>
-        <p:nvSpPr>
-          <p:cNvPr id="10" name="TextBox 9"/>
+              <a:t>OGC API – Moving Features – Part 1: Core</a:t>
+            </a:r>
+          </a:p>
+        </p:txBody>
+      </p:sp>
+      <p:sp>
+        <p:nvSpPr>
+          <p:cNvPr id="7" name="TextBox 6"/>
           <p:cNvSpPr txBox="1"/>
           <p:nvPr/>
         </p:nvSpPr>
         <p:spPr>
           <a:xfrm>
-            <a:off x="932688" y="2842384"/>
+            <a:off x="932688" y="1792224"/>
             <a:ext cx="10515600" cy="292608"/>
           </a:xfrm>
           <a:prstGeom prst="rect">
@@ -31303,41 +31333,22 @@
                   <a:srgbClr val="156082"/>
                 </a:solidFill>
                 <a:latin typeface="Consolas"/>
-                <a:hlinkClick r:id="rId3"/>
-              </a:rPr>
-              <a:t>https://github.com/MobilityDB/MobilityDB</a:t>
-            </a:r>
-            <a:r>
-              <a:rPr sz="1200">
-                <a:solidFill>
-                  <a:srgbClr val="5B6B78"/>
-                </a:solidFill>
-                <a:latin typeface="Consolas"/>
-              </a:rPr>
-              <a:t>    ·    </a:t>
-            </a:r>
-            <a:r>
-              <a:rPr sz="1200" u="none">
-                <a:solidFill>
-                  <a:srgbClr val="156082"/>
-                </a:solidFill>
-                <a:latin typeface="Consolas"/>
-                <a:hlinkClick r:id="rId4"/>
-              </a:rPr>
-              <a:t>https://mobilitydb.com</a:t>
-            </a:r>
-          </a:p>
-        </p:txBody>
-      </p:sp>
-      <p:sp>
-        <p:nvSpPr>
-          <p:cNvPr id="11" name="Rectangle 10"/>
+                <a:hlinkClick r:id="rId2"/>
+              </a:rPr>
+              <a:t>https://docs.ogc.org/is/22-003r3/22-003r3.html</a:t>
+            </a:r>
+          </a:p>
+        </p:txBody>
+      </p:sp>
+      <p:sp>
+        <p:nvSpPr>
+          <p:cNvPr id="8" name="Rectangle 7"/>
           <p:cNvSpPr/>
           <p:nvPr/>
         </p:nvSpPr>
         <p:spPr>
           <a:xfrm>
-            <a:off x="566928" y="3445887"/>
+            <a:off x="566928" y="2267712"/>
             <a:ext cx="164592" cy="164592"/>
           </a:xfrm>
           <a:prstGeom prst="rect">
@@ -31376,13 +31387,13 @@
       </p:sp>
       <p:sp>
         <p:nvSpPr>
-          <p:cNvPr id="12" name="TextBox 11"/>
+          <p:cNvPr id="9" name="TextBox 8"/>
           <p:cNvSpPr txBox="1"/>
           <p:nvPr/>
         </p:nvSpPr>
         <p:spPr>
           <a:xfrm>
-            <a:off x="932688" y="3372736"/>
+            <a:off x="932688" y="2194560"/>
             <a:ext cx="8686800" cy="320040"/>
           </a:xfrm>
           <a:prstGeom prst="rect">
@@ -31411,20 +31422,20 @@
                 </a:solidFill>
                 <a:latin typeface="Calibri"/>
               </a:rPr>
-              <a:t>MEOS / ecosystem overview</a:t>
-            </a:r>
-          </a:p>
-        </p:txBody>
-      </p:sp>
-      <p:sp>
-        <p:nvSpPr>
-          <p:cNvPr id="13" name="TextBox 12"/>
+              <a:t>MobilityDB</a:t>
+            </a:r>
+          </a:p>
+        </p:txBody>
+      </p:sp>
+      <p:sp>
+        <p:nvSpPr>
+          <p:cNvPr id="10" name="TextBox 9"/>
           <p:cNvSpPr txBox="1"/>
           <p:nvPr/>
         </p:nvSpPr>
         <p:spPr>
           <a:xfrm>
-            <a:off x="932688" y="3683632"/>
+            <a:off x="932688" y="2505456"/>
             <a:ext cx="10515600" cy="292608"/>
           </a:xfrm>
           <a:prstGeom prst="rect">
@@ -31445,22 +31456,41 @@
                   <a:srgbClr val="156082"/>
                 </a:solidFill>
                 <a:latin typeface="Consolas"/>
-                <a:hlinkClick r:id="rId5"/>
-              </a:rPr>
-              <a:t>https://libmeos.org</a:t>
-            </a:r>
-          </a:p>
-        </p:txBody>
-      </p:sp>
-      <p:sp>
-        <p:nvSpPr>
-          <p:cNvPr id="14" name="Rectangle 13"/>
+                <a:hlinkClick r:id="rId3"/>
+              </a:rPr>
+              <a:t>https://github.com/MobilityDB/MobilityDB</a:t>
+            </a:r>
+            <a:r>
+              <a:rPr sz="1200">
+                <a:solidFill>
+                  <a:srgbClr val="5B6B78"/>
+                </a:solidFill>
+                <a:latin typeface="Consolas"/>
+              </a:rPr>
+              <a:t>    ·    </a:t>
+            </a:r>
+            <a:r>
+              <a:rPr sz="1200" u="none">
+                <a:solidFill>
+                  <a:srgbClr val="156082"/>
+                </a:solidFill>
+                <a:latin typeface="Consolas"/>
+                <a:hlinkClick r:id="rId4"/>
+              </a:rPr>
+              <a:t>https://mobilitydb.com</a:t>
+            </a:r>
+          </a:p>
+        </p:txBody>
+      </p:sp>
+      <p:sp>
+        <p:nvSpPr>
+          <p:cNvPr id="11" name="Rectangle 10"/>
           <p:cNvSpPr/>
           <p:nvPr/>
         </p:nvSpPr>
         <p:spPr>
           <a:xfrm>
-            <a:off x="566928" y="4287136"/>
+            <a:off x="566928" y="2980944"/>
             <a:ext cx="164592" cy="164592"/>
           </a:xfrm>
           <a:prstGeom prst="rect">
@@ -31499,13 +31529,13 @@
       </p:sp>
       <p:sp>
         <p:nvSpPr>
-          <p:cNvPr id="15" name="TextBox 14"/>
+          <p:cNvPr id="12" name="TextBox 11"/>
           <p:cNvSpPr txBox="1"/>
           <p:nvPr/>
         </p:nvSpPr>
         <p:spPr>
           <a:xfrm>
-            <a:off x="932688" y="4213984"/>
+            <a:off x="932688" y="2907792"/>
             <a:ext cx="8686800" cy="320040"/>
           </a:xfrm>
           <a:prstGeom prst="rect">
@@ -31534,6 +31564,129 @@
                 </a:solidFill>
                 <a:latin typeface="Calibri"/>
               </a:rPr>
+              <a:t>MEOS / ecosystem overview</a:t>
+            </a:r>
+          </a:p>
+        </p:txBody>
+      </p:sp>
+      <p:sp>
+        <p:nvSpPr>
+          <p:cNvPr id="13" name="TextBox 12"/>
+          <p:cNvSpPr txBox="1"/>
+          <p:nvPr/>
+        </p:nvSpPr>
+        <p:spPr>
+          <a:xfrm>
+            <a:off x="932688" y="3218688"/>
+            <a:ext cx="10515600" cy="292608"/>
+          </a:xfrm>
+          <a:prstGeom prst="rect">
+            <a:avLst/>
+          </a:prstGeom>
+          <a:noFill/>
+        </p:spPr>
+        <p:txBody>
+          <a:bodyPr wrap="none" lIns="0" tIns="0" rIns="0" bIns="0">
+            <a:noAutofit/>
+          </a:bodyPr>
+          <a:lstStyle/>
+          <a:p>
+            <a:pPr algn="l"/>
+            <a:r>
+              <a:rPr sz="1200" u="none">
+                <a:solidFill>
+                  <a:srgbClr val="156082"/>
+                </a:solidFill>
+                <a:latin typeface="Consolas"/>
+                <a:hlinkClick r:id="rId5"/>
+              </a:rPr>
+              <a:t>https://libmeos.org</a:t>
+            </a:r>
+          </a:p>
+        </p:txBody>
+      </p:sp>
+      <p:sp>
+        <p:nvSpPr>
+          <p:cNvPr id="14" name="Rectangle 13"/>
+          <p:cNvSpPr/>
+          <p:nvPr/>
+        </p:nvSpPr>
+        <p:spPr>
+          <a:xfrm>
+            <a:off x="566928" y="3694176"/>
+            <a:ext cx="164592" cy="164592"/>
+          </a:xfrm>
+          <a:prstGeom prst="rect">
+            <a:avLst/>
+          </a:prstGeom>
+          <a:solidFill>
+            <a:srgbClr val="156082"/>
+          </a:solidFill>
+          <a:ln>
+            <a:noFill/>
+          </a:ln>
+          <a:effectLst/>
+        </p:spPr>
+        <p:style>
+          <a:lnRef idx="1">
+            <a:schemeClr val="accent1"/>
+          </a:lnRef>
+          <a:fillRef idx="3">
+            <a:schemeClr val="accent1"/>
+          </a:fillRef>
+          <a:effectRef idx="2">
+            <a:schemeClr val="accent1"/>
+          </a:effectRef>
+          <a:fontRef idx="minor">
+            <a:schemeClr val="lt1"/>
+          </a:fontRef>
+        </p:style>
+        <p:txBody>
+          <a:bodyPr rtlCol="0" anchor="ctr"/>
+          <a:lstStyle/>
+          <a:p>
+            <a:pPr algn="ctr"/>
+            <a:endParaRPr/>
+          </a:p>
+        </p:txBody>
+      </p:sp>
+      <p:sp>
+        <p:nvSpPr>
+          <p:cNvPr id="15" name="TextBox 14"/>
+          <p:cNvSpPr txBox="1"/>
+          <p:nvPr/>
+        </p:nvSpPr>
+        <p:spPr>
+          <a:xfrm>
+            <a:off x="932688" y="3621024"/>
+            <a:ext cx="8686800" cy="320040"/>
+          </a:xfrm>
+          <a:prstGeom prst="rect">
+            <a:avLst/>
+          </a:prstGeom>
+          <a:noFill/>
+        </p:spPr>
+        <p:txBody>
+          <a:bodyPr wrap="square" lIns="0" tIns="0" rIns="0" bIns="0" anchor="t">
+            <a:noAutofit/>
+          </a:bodyPr>
+          <a:lstStyle/>
+          <a:p>
+            <a:pPr algn="l">
+              <a:spcBef>
+                <a:spcPts val="0"/>
+              </a:spcBef>
+              <a:spcAft>
+                <a:spcPts val="200"/>
+              </a:spcAft>
+            </a:pPr>
+            <a:r>
+              <a:rPr sz="1400" b="1" i="0">
+                <a:solidFill>
+                  <a:srgbClr val="0E2841"/>
+                </a:solidFill>
+                <a:latin typeface="Calibri"/>
+              </a:rPr>
               <a:t>AIS data — Danish Maritime Authority</a:t>
             </a:r>
           </a:p>
@@ -31547,7 +31700,7 @@
         </p:nvSpPr>
         <p:spPr>
           <a:xfrm>
-            <a:off x="932688" y="4524880"/>
+            <a:off x="932688" y="3931920"/>
             <a:ext cx="10515600" cy="292608"/>
           </a:xfrm>
           <a:prstGeom prst="rect">
@@ -31712,7 +31865,7 @@
         </p:nvSpPr>
         <p:spPr>
           <a:xfrm>
-            <a:off x="566928" y="5128384"/>
+            <a:off x="566928" y="4407408"/>
             <a:ext cx="164592" cy="164592"/>
           </a:xfrm>
           <a:prstGeom prst="rect">
@@ -31757,7 +31910,7 @@
         </p:nvSpPr>
         <p:spPr>
           <a:xfrm>
-            <a:off x="932688" y="5055232"/>
+            <a:off x="932688" y="4334256"/>
             <a:ext cx="8686800" cy="320040"/>
           </a:xfrm>
           <a:prstGeom prst="rect">
@@ -31799,7 +31952,7 @@
         </p:nvSpPr>
         <p:spPr>
           <a:xfrm>
-            <a:off x="932688" y="5366128"/>
+            <a:off x="932688" y="4645152"/>
             <a:ext cx="10515600" cy="292608"/>
           </a:xfrm>
           <a:prstGeom prst="rect">
@@ -31835,7 +31988,7 @@
         </p:nvSpPr>
         <p:spPr>
           <a:xfrm>
-            <a:off x="566928" y="5969632"/>
+            <a:off x="566928" y="5120640"/>
             <a:ext cx="164592" cy="164592"/>
           </a:xfrm>
           <a:prstGeom prst="rect">
@@ -31880,7 +32033,7 @@
         </p:nvSpPr>
         <p:spPr>
           <a:xfrm>
-            <a:off x="932688" y="5896480"/>
+            <a:off x="932688" y="5047488"/>
             <a:ext cx="8686800" cy="320040"/>
           </a:xfrm>
           <a:prstGeom prst="rect">
@@ -31916,13 +32069,55 @@
       </p:sp>
       <p:sp>
         <p:nvSpPr>
+          <p:cNvPr id="21" name="TextBox 20"/>
+          <p:cNvSpPr txBox="1"/>
+          <p:nvPr/>
+        </p:nvSpPr>
+        <p:spPr>
+          <a:xfrm>
+            <a:off x="932688" y="5760720"/>
+            <a:ext cx="8686800" cy="320040"/>
+          </a:xfrm>
+          <a:prstGeom prst="rect">
+            <a:avLst/>
+          </a:prstGeom>
+          <a:noFill/>
+        </p:spPr>
+        <p:txBody>
+          <a:bodyPr wrap="square" lIns="0" tIns="0" rIns="0" bIns="0" anchor="t">
+            <a:noAutofit/>
+          </a:bodyPr>
+          <a:lstStyle/>
+          <a:p>
+            <a:pPr algn="l">
+              <a:spcBef>
+                <a:spcPts val="0"/>
+              </a:spcBef>
+              <a:spcAft>
+                <a:spcPts val="200"/>
+              </a:spcAft>
+            </a:pPr>
+            <a:r>
+              <a:rPr sz="1400" b="1" i="0">
+                <a:solidFill>
+                  <a:srgbClr val="0E2841"/>
+                </a:solidFill>
+                <a:latin typeface="Calibri"/>
+              </a:rPr>
+              <a:t>OGC MF API reference implementation — aistairc/mf-api</a:t>
+            </a:r>
+          </a:p>
+        </p:txBody>
+      </p:sp>
+      <p:sp>
+        <p:nvSpPr>
           <p:cNvPr id="22" name="TextBox 21"/>
           <p:cNvSpPr txBox="1"/>
           <p:nvPr/>
         </p:nvSpPr>
         <p:spPr>
           <a:xfrm>
-            <a:off x="932688" y="6207376"/>
+            <a:off x="932688" y="5358384"/>
             <a:ext cx="10515600" cy="292608"/>
           </a:xfrm>
           <a:prstGeom prst="rect">
@@ -31946,6 +32141,42 @@
                 <a:hlinkClick r:id="rId7"/>
               </a:rPr>
               <a:t>https://github.com/MobilityDB/MobilityAPI-Python</a:t>
+            </a:r>
+          </a:p>
+        </p:txBody>
+      </p:sp>
+      <p:sp>
+        <p:nvSpPr>
+          <p:cNvPr id="22" name="TextBox 21"/>
+          <p:cNvSpPr txBox="1"/>
+          <p:nvPr/>
+        </p:nvSpPr>
+        <p:spPr>
+          <a:xfrm>
+            <a:off x="932688" y="6071616"/>
+            <a:ext cx="10515600" cy="292608"/>
+          </a:xfrm>
+          <a:prstGeom prst="rect">
+            <a:avLst/>
+          </a:prstGeom>
+          <a:noFill/>
+        </p:spPr>
+        <p:txBody>
+          <a:bodyPr wrap="none" lIns="0" tIns="0" rIns="0" bIns="0">
+            <a:noAutofit/>
+          </a:bodyPr>
+          <a:lstStyle/>
+          <a:p>
+            <a:pPr algn="l"/>
+            <a:r>
+              <a:rPr sz="1200" u="none">
+                <a:solidFill>
+                  <a:srgbClr val="156082"/>
+                </a:solidFill>
+                <a:latin typeface="Consolas"/>
+                <a:hlinkClick r:id="rId7"/>
+              </a:rPr>
+              <a:t>https://github.com/aistairc/mf-api</a:t>
             </a:r>
           </a:p>
         </p:txBody>

</xml_diff>